<commit_message>
Add Future Vision slide (AI-run finance) with diagram; standalone file
Co-authored-by: ausjiwgeorge <ausjiwgeorge@users.noreply.github.com>
</commit_message>
<xml_diff>
--- a/CFO_Agenda_and_Roadmap_EN.pptx
+++ b/CFO_Agenda_and_Roadmap_EN.pptx
@@ -4993,7 +4993,7 @@
         </p:nvSpPr>
         <p:spPr>
           <a:xfrm>
-            <a:off x="6263640" y="1417320"/>
+            <a:off x="640080" y="5916168"/>
             <a:ext cx="566928" cy="566928"/>
           </a:xfrm>
           <a:prstGeom prst="rect">
@@ -5037,7 +5037,7 @@
         </p:nvSpPr>
         <p:spPr>
           <a:xfrm>
-            <a:off x="6263640" y="1481328"/>
+            <a:off x="640080" y="5980176"/>
             <a:ext cx="566928" cy="457200"/>
           </a:xfrm>
           <a:prstGeom prst="rect">
@@ -5079,7 +5079,7 @@
         </p:nvSpPr>
         <p:spPr>
           <a:xfrm>
-            <a:off x="6995160" y="1435608"/>
+            <a:off x="1371600" y="5934456"/>
             <a:ext cx="4480560" cy="365760"/>
           </a:xfrm>
           <a:prstGeom prst="rect">
@@ -5121,7 +5121,7 @@
         </p:nvSpPr>
         <p:spPr>
           <a:xfrm>
-            <a:off x="6995160" y="1755648"/>
+            <a:off x="1371600" y="6254496"/>
             <a:ext cx="4480560" cy="320040"/>
           </a:xfrm>
           <a:prstGeom prst="rect">
@@ -5163,7 +5163,7 @@
         </p:nvSpPr>
         <p:spPr>
           <a:xfrm>
-            <a:off x="6263640" y="2167128"/>
+            <a:off x="6263640" y="1417320"/>
             <a:ext cx="566928" cy="566928"/>
           </a:xfrm>
           <a:prstGeom prst="rect">
@@ -5207,7 +5207,7 @@
         </p:nvSpPr>
         <p:spPr>
           <a:xfrm>
-            <a:off x="6263640" y="2231136"/>
+            <a:off x="6263640" y="1481328"/>
             <a:ext cx="566928" cy="457200"/>
           </a:xfrm>
           <a:prstGeom prst="rect">
@@ -5249,7 +5249,7 @@
         </p:nvSpPr>
         <p:spPr>
           <a:xfrm>
-            <a:off x="6995160" y="2185416"/>
+            <a:off x="6995160" y="1435608"/>
             <a:ext cx="4480560" cy="365760"/>
           </a:xfrm>
           <a:prstGeom prst="rect">
@@ -5291,7 +5291,7 @@
         </p:nvSpPr>
         <p:spPr>
           <a:xfrm>
-            <a:off x="6995160" y="2505456"/>
+            <a:off x="6995160" y="1755648"/>
             <a:ext cx="4480560" cy="320040"/>
           </a:xfrm>
           <a:prstGeom prst="rect">
@@ -5333,7 +5333,7 @@
         </p:nvSpPr>
         <p:spPr>
           <a:xfrm>
-            <a:off x="6263640" y="2916936"/>
+            <a:off x="6263640" y="2167128"/>
             <a:ext cx="566928" cy="566928"/>
           </a:xfrm>
           <a:prstGeom prst="rect">
@@ -5377,7 +5377,7 @@
         </p:nvSpPr>
         <p:spPr>
           <a:xfrm>
-            <a:off x="6263640" y="2980944"/>
+            <a:off x="6263640" y="2231136"/>
             <a:ext cx="566928" cy="457200"/>
           </a:xfrm>
           <a:prstGeom prst="rect">
@@ -5419,7 +5419,7 @@
         </p:nvSpPr>
         <p:spPr>
           <a:xfrm>
-            <a:off x="6995160" y="2935224"/>
+            <a:off x="6995160" y="2185416"/>
             <a:ext cx="4480560" cy="365760"/>
           </a:xfrm>
           <a:prstGeom prst="rect">
@@ -5461,7 +5461,7 @@
         </p:nvSpPr>
         <p:spPr>
           <a:xfrm>
-            <a:off x="6995160" y="3255264"/>
+            <a:off x="6995160" y="2505456"/>
             <a:ext cx="4480560" cy="320040"/>
           </a:xfrm>
           <a:prstGeom prst="rect">
@@ -5503,7 +5503,7 @@
         </p:nvSpPr>
         <p:spPr>
           <a:xfrm>
-            <a:off x="6263640" y="3666744"/>
+            <a:off x="6263640" y="2916936"/>
             <a:ext cx="566928" cy="566928"/>
           </a:xfrm>
           <a:prstGeom prst="rect">
@@ -5547,7 +5547,7 @@
         </p:nvSpPr>
         <p:spPr>
           <a:xfrm>
-            <a:off x="6263640" y="3730752"/>
+            <a:off x="6263640" y="2980944"/>
             <a:ext cx="566928" cy="457200"/>
           </a:xfrm>
           <a:prstGeom prst="rect">
@@ -5589,7 +5589,7 @@
         </p:nvSpPr>
         <p:spPr>
           <a:xfrm>
-            <a:off x="6995160" y="3685032"/>
+            <a:off x="6995160" y="2935224"/>
             <a:ext cx="4480560" cy="365760"/>
           </a:xfrm>
           <a:prstGeom prst="rect">
@@ -5631,7 +5631,7 @@
         </p:nvSpPr>
         <p:spPr>
           <a:xfrm>
-            <a:off x="6995160" y="4005072"/>
+            <a:off x="6995160" y="3255264"/>
             <a:ext cx="4480560" cy="320040"/>
           </a:xfrm>
           <a:prstGeom prst="rect">
@@ -5673,7 +5673,7 @@
         </p:nvSpPr>
         <p:spPr>
           <a:xfrm>
-            <a:off x="6263640" y="4416552"/>
+            <a:off x="6263640" y="3666744"/>
             <a:ext cx="566928" cy="566928"/>
           </a:xfrm>
           <a:prstGeom prst="rect">
@@ -5717,7 +5717,7 @@
         </p:nvSpPr>
         <p:spPr>
           <a:xfrm>
-            <a:off x="6263640" y="4480560"/>
+            <a:off x="6263640" y="3730752"/>
             <a:ext cx="566928" cy="457200"/>
           </a:xfrm>
           <a:prstGeom prst="rect">
@@ -5759,7 +5759,7 @@
         </p:nvSpPr>
         <p:spPr>
           <a:xfrm>
-            <a:off x="6995160" y="4434840"/>
+            <a:off x="6995160" y="3685032"/>
             <a:ext cx="4480560" cy="365760"/>
           </a:xfrm>
           <a:prstGeom prst="rect">
@@ -5801,7 +5801,7 @@
         </p:nvSpPr>
         <p:spPr>
           <a:xfrm>
-            <a:off x="6995160" y="4754880"/>
+            <a:off x="6995160" y="4005072"/>
             <a:ext cx="4480560" cy="320040"/>
           </a:xfrm>
           <a:prstGeom prst="rect">
@@ -5843,7 +5843,7 @@
         </p:nvSpPr>
         <p:spPr>
           <a:xfrm>
-            <a:off x="6263640" y="5166360"/>
+            <a:off x="6263640" y="4416552"/>
             <a:ext cx="566928" cy="566928"/>
           </a:xfrm>
           <a:prstGeom prst="rect">
@@ -5887,7 +5887,7 @@
         </p:nvSpPr>
         <p:spPr>
           <a:xfrm>
-            <a:off x="6263640" y="5230368"/>
+            <a:off x="6263640" y="4480560"/>
             <a:ext cx="566928" cy="457200"/>
           </a:xfrm>
           <a:prstGeom prst="rect">
@@ -5929,7 +5929,7 @@
         </p:nvSpPr>
         <p:spPr>
           <a:xfrm>
-            <a:off x="6995160" y="5184648"/>
+            <a:off x="6995160" y="4434840"/>
             <a:ext cx="4480560" cy="365760"/>
           </a:xfrm>
           <a:prstGeom prst="rect">
@@ -5958,6 +5958,176 @@
                 </a:solidFill>
                 <a:latin typeface="Calibri"/>
               </a:rPr>
+              <a:t>Future Vision — AI-run Finance</a:t>
+            </a:r>
+          </a:p>
+        </p:txBody>
+      </p:sp>
+      <p:sp>
+        <p:nvSpPr>
+          <p:cNvPr id="58" name="TextBox 57"/>
+          <p:cNvSpPr txBox="1"/>
+          <p:nvPr/>
+        </p:nvSpPr>
+        <p:spPr>
+          <a:xfrm>
+            <a:off x="6995160" y="4754880"/>
+            <a:ext cx="4480560" cy="320040"/>
+          </a:xfrm>
+          <a:prstGeom prst="rect">
+            <a:avLst/>
+          </a:prstGeom>
+          <a:noFill/>
+        </p:spPr>
+        <p:txBody>
+          <a:bodyPr wrap="square" anchor="t">
+            <a:spAutoFit/>
+          </a:bodyPr>
+          <a:lstStyle/>
+          <a:p>
+            <a:pPr algn="l">
+              <a:lnSpc>
+                <a:spcPct val="105000"/>
+              </a:lnSpc>
+              <a:spcAft>
+                <a:spcPts val="600"/>
+              </a:spcAft>
+            </a:pPr>
+            <a:r>
+              <a:rPr sz="1100" b="0">
+                <a:solidFill>
+                  <a:srgbClr val="5A6B7B"/>
+                </a:solidFill>
+                <a:latin typeface="Calibri"/>
+              </a:rPr>
+              <a:t>AI executes; people manage &amp; create</a:t>
+            </a:r>
+          </a:p>
+        </p:txBody>
+      </p:sp>
+      <p:sp>
+        <p:nvSpPr>
+          <p:cNvPr id="59" name="Rectangle 58"/>
+          <p:cNvSpPr/>
+          <p:nvPr/>
+        </p:nvSpPr>
+        <p:spPr>
+          <a:xfrm>
+            <a:off x="6263640" y="5166360"/>
+            <a:ext cx="566928" cy="566928"/>
+          </a:xfrm>
+          <a:prstGeom prst="rect">
+            <a:avLst/>
+          </a:prstGeom>
+          <a:solidFill>
+            <a:srgbClr val="1F3A5F"/>
+          </a:solidFill>
+          <a:ln>
+            <a:noFill/>
+          </a:ln>
+          <a:effectLst/>
+        </p:spPr>
+        <p:style>
+          <a:lnRef idx="1">
+            <a:schemeClr val="accent1"/>
+          </a:lnRef>
+          <a:fillRef idx="3">
+            <a:schemeClr val="accent1"/>
+          </a:fillRef>
+          <a:effectRef idx="2">
+            <a:schemeClr val="accent1"/>
+          </a:effectRef>
+          <a:fontRef idx="minor">
+            <a:schemeClr val="lt1"/>
+          </a:fontRef>
+        </p:style>
+        <p:txBody>
+          <a:bodyPr rtlCol="0" anchor="ctr"/>
+          <a:lstStyle/>
+          <a:p>
+            <a:pPr algn="ctr"/>
+          </a:p>
+        </p:txBody>
+      </p:sp>
+      <p:sp>
+        <p:nvSpPr>
+          <p:cNvPr id="60" name="TextBox 59"/>
+          <p:cNvSpPr txBox="1"/>
+          <p:nvPr/>
+        </p:nvSpPr>
+        <p:spPr>
+          <a:xfrm>
+            <a:off x="6263640" y="5230368"/>
+            <a:ext cx="566928" cy="457200"/>
+          </a:xfrm>
+          <a:prstGeom prst="rect">
+            <a:avLst/>
+          </a:prstGeom>
+          <a:noFill/>
+        </p:spPr>
+        <p:txBody>
+          <a:bodyPr wrap="square" anchor="t">
+            <a:spAutoFit/>
+          </a:bodyPr>
+          <a:lstStyle/>
+          <a:p>
+            <a:pPr algn="ctr">
+              <a:lnSpc>
+                <a:spcPct val="105000"/>
+              </a:lnSpc>
+              <a:spcAft>
+                <a:spcPts val="600"/>
+              </a:spcAft>
+            </a:pPr>
+            <a:r>
+              <a:rPr sz="1500" b="1">
+                <a:solidFill>
+                  <a:srgbClr val="FFFFFF"/>
+                </a:solidFill>
+                <a:latin typeface="Calibri"/>
+              </a:rPr>
+              <a:t>13</a:t>
+            </a:r>
+          </a:p>
+        </p:txBody>
+      </p:sp>
+      <p:sp>
+        <p:nvSpPr>
+          <p:cNvPr id="61" name="TextBox 60"/>
+          <p:cNvSpPr txBox="1"/>
+          <p:nvPr/>
+        </p:nvSpPr>
+        <p:spPr>
+          <a:xfrm>
+            <a:off x="6995160" y="5184648"/>
+            <a:ext cx="4480560" cy="365760"/>
+          </a:xfrm>
+          <a:prstGeom prst="rect">
+            <a:avLst/>
+          </a:prstGeom>
+          <a:noFill/>
+        </p:spPr>
+        <p:txBody>
+          <a:bodyPr wrap="square" anchor="t">
+            <a:spAutoFit/>
+          </a:bodyPr>
+          <a:lstStyle/>
+          <a:p>
+            <a:pPr algn="l">
+              <a:lnSpc>
+                <a:spcPct val="105000"/>
+              </a:lnSpc>
+              <a:spcAft>
+                <a:spcPts val="600"/>
+              </a:spcAft>
+            </a:pPr>
+            <a:r>
+              <a:rPr sz="1450" b="1">
+                <a:solidFill>
+                  <a:srgbClr val="1F3A5F"/>
+                </a:solidFill>
+                <a:latin typeface="Calibri"/>
+              </a:rPr>
               <a:t>First 90 Days &amp; The Ask</a:t>
             </a:r>
           </a:p>
@@ -5965,7 +6135,7 @@
       </p:sp>
       <p:sp>
         <p:nvSpPr>
-          <p:cNvPr id="58" name="TextBox 57"/>
+          <p:cNvPr id="62" name="TextBox 61"/>
           <p:cNvSpPr txBox="1"/>
           <p:nvPr/>
         </p:nvSpPr>

</xml_diff>